<commit_message>
Reflect July GA on batch comparison chart
Add July as a distinct amber series for GA (all accounts) with no
per-domain counts, keep May/June BETA batch numbers, and update the
slide data table/legend accordingly.

Co-authored-by: maiagordon-commits <maiagordon-commits@users.noreply.github.com>
</commit_message>
<xml_diff>
--- a/accounts_comparison_per_batch.pptx
+++ b/accounts_comparison_per_batch.pptx
@@ -3114,7 +3114,7 @@
         <p:spPr>
           <a:xfrm>
             <a:off x="502920" y="320040"/>
-            <a:ext cx="11155680" cy="6474669"/>
+            <a:ext cx="11155680" cy="6849650"/>
           </a:xfrm>
           <a:prstGeom prst="rect">
             <a:avLst/>
@@ -3264,8 +3264,8 @@
           <p:nvPr/>
         </p:nvGraphicFramePr>
         <p:xfrm>
-          <a:off x="1097280" y="1463040"/>
-          <a:ext cx="8595360" cy="4389120"/>
+          <a:off x="640080" y="1371600"/>
+          <a:ext cx="10424160" cy="4206240"/>
         </p:xfrm>
         <a:graphic>
           <a:graphicData uri="http://schemas.openxmlformats.org/drawingml/2006/table">
@@ -3274,12 +3274,13 @@
                 <a:tableStyleId>{5C22544A-7EE6-4342-B048-85BDC9FD1C3A}</a:tableStyleId>
               </a:tblPr>
               <a:tblGrid>
+                <a:gridCol w="2011680"/>
                 <a:gridCol w="2194560"/>
-                <a:gridCol w="2377440"/>
-                <a:gridCol w="2377440"/>
-                <a:gridCol w="1645920"/>
+                <a:gridCol w="2194560"/>
+                <a:gridCol w="2011680"/>
+                <a:gridCol w="2011680"/>
               </a:tblGrid>
-              <a:tr h="548640">
+              <a:tr h="525780">
                 <a:tc>
                   <a:txBody>
                     <a:bodyPr/>
@@ -3366,7 +3367,31 @@
                         </a:defRPr>
                       </a:pPr>
                       <a:r>
-                        <a:t>Total</a:t>
+                        <a:t>July</a:t>
+                      </a:r>
+                    </a:p>
+                  </a:txBody>
+                  <a:tcPr>
+                    <a:solidFill>
+                      <a:srgbClr val="2D4B1E"/>
+                    </a:solidFill>
+                  </a:tcPr>
+                </a:tc>
+                <a:tc>
+                  <a:txBody>
+                    <a:bodyPr/>
+                    <a:lstStyle/>
+                    <a:p>
+                      <a:pPr>
+                        <a:defRPr sz="1100" b="1">
+                          <a:solidFill>
+                            <a:srgbClr val="FFFFFF"/>
+                          </a:solidFill>
+                          <a:latin typeface="Arial"/>
+                        </a:defRPr>
+                      </a:pPr>
+                      <a:r>
+                        <a:t>May+Jun Total</a:t>
                       </a:r>
                     </a:p>
                   </a:txBody>
@@ -3377,7 +3402,7 @@
                   </a:tcPr>
                 </a:tc>
               </a:tr>
-              <a:tr h="548640">
+              <a:tr h="525780">
                 <a:tc>
                   <a:txBody>
                     <a:bodyPr/>
@@ -3452,6 +3477,26 @@
                         </a:defRPr>
                       </a:pPr>
                       <a:r>
+                        <a:t>GA (all)</a:t>
+                      </a:r>
+                    </a:p>
+                  </a:txBody>
+                  <a:tcPr/>
+                </a:tc>
+                <a:tc>
+                  <a:txBody>
+                    <a:bodyPr/>
+                    <a:lstStyle/>
+                    <a:p>
+                      <a:pPr>
+                        <a:defRPr sz="1000" b="0">
+                          <a:solidFill>
+                            <a:srgbClr val="1E293B"/>
+                          </a:solidFill>
+                          <a:latin typeface="Arial"/>
+                        </a:defRPr>
+                      </a:pPr>
+                      <a:r>
                         <a:t>19</a:t>
                       </a:r>
                     </a:p>
@@ -3459,7 +3504,7 @@
                   <a:tcPr/>
                 </a:tc>
               </a:tr>
-              <a:tr h="548640">
+              <a:tr h="525780">
                 <a:tc>
                   <a:txBody>
                     <a:bodyPr/>
@@ -3534,6 +3579,26 @@
                         </a:defRPr>
                       </a:pPr>
                       <a:r>
+                        <a:t>GA (all)</a:t>
+                      </a:r>
+                    </a:p>
+                  </a:txBody>
+                  <a:tcPr/>
+                </a:tc>
+                <a:tc>
+                  <a:txBody>
+                    <a:bodyPr/>
+                    <a:lstStyle/>
+                    <a:p>
+                      <a:pPr>
+                        <a:defRPr sz="1000" b="0">
+                          <a:solidFill>
+                            <a:srgbClr val="1E293B"/>
+                          </a:solidFill>
+                          <a:latin typeface="Arial"/>
+                        </a:defRPr>
+                      </a:pPr>
+                      <a:r>
                         <a:t>2</a:t>
                       </a:r>
                     </a:p>
@@ -3541,7 +3606,7 @@
                   <a:tcPr/>
                 </a:tc>
               </a:tr>
-              <a:tr h="548640">
+              <a:tr h="525780">
                 <a:tc>
                   <a:txBody>
                     <a:bodyPr/>
@@ -3616,6 +3681,26 @@
                         </a:defRPr>
                       </a:pPr>
                       <a:r>
+                        <a:t>GA (all)</a:t>
+                      </a:r>
+                    </a:p>
+                  </a:txBody>
+                  <a:tcPr/>
+                </a:tc>
+                <a:tc>
+                  <a:txBody>
+                    <a:bodyPr/>
+                    <a:lstStyle/>
+                    <a:p>
+                      <a:pPr>
+                        <a:defRPr sz="1000" b="0">
+                          <a:solidFill>
+                            <a:srgbClr val="1E293B"/>
+                          </a:solidFill>
+                          <a:latin typeface="Arial"/>
+                        </a:defRPr>
+                      </a:pPr>
+                      <a:r>
                         <a:t>2</a:t>
                       </a:r>
                     </a:p>
@@ -3623,7 +3708,7 @@
                   <a:tcPr/>
                 </a:tc>
               </a:tr>
-              <a:tr h="548640">
+              <a:tr h="525780">
                 <a:tc>
                   <a:txBody>
                     <a:bodyPr/>
@@ -3698,6 +3783,26 @@
                         </a:defRPr>
                       </a:pPr>
                       <a:r>
+                        <a:t>GA (all)</a:t>
+                      </a:r>
+                    </a:p>
+                  </a:txBody>
+                  <a:tcPr/>
+                </a:tc>
+                <a:tc>
+                  <a:txBody>
+                    <a:bodyPr/>
+                    <a:lstStyle/>
+                    <a:p>
+                      <a:pPr>
+                        <a:defRPr sz="1000" b="0">
+                          <a:solidFill>
+                            <a:srgbClr val="1E293B"/>
+                          </a:solidFill>
+                          <a:latin typeface="Arial"/>
+                        </a:defRPr>
+                      </a:pPr>
+                      <a:r>
                         <a:t>2</a:t>
                       </a:r>
                     </a:p>
@@ -3705,7 +3810,7 @@
                   <a:tcPr/>
                 </a:tc>
               </a:tr>
-              <a:tr h="548640">
+              <a:tr h="525780">
                 <a:tc>
                   <a:txBody>
                     <a:bodyPr/>
@@ -3780,6 +3885,26 @@
                         </a:defRPr>
                       </a:pPr>
                       <a:r>
+                        <a:t>GA (all)</a:t>
+                      </a:r>
+                    </a:p>
+                  </a:txBody>
+                  <a:tcPr/>
+                </a:tc>
+                <a:tc>
+                  <a:txBody>
+                    <a:bodyPr/>
+                    <a:lstStyle/>
+                    <a:p>
+                      <a:pPr>
+                        <a:defRPr sz="1000" b="0">
+                          <a:solidFill>
+                            <a:srgbClr val="1E293B"/>
+                          </a:solidFill>
+                          <a:latin typeface="Arial"/>
+                        </a:defRPr>
+                      </a:pPr>
+                      <a:r>
                         <a:t>2</a:t>
                       </a:r>
                     </a:p>
@@ -3787,7 +3912,7 @@
                   <a:tcPr/>
                 </a:tc>
               </a:tr>
-              <a:tr h="548640">
+              <a:tr h="525780">
                 <a:tc>
                   <a:txBody>
                     <a:bodyPr/>
@@ -3862,6 +3987,26 @@
                         </a:defRPr>
                       </a:pPr>
                       <a:r>
+                        <a:t>GA (all)</a:t>
+                      </a:r>
+                    </a:p>
+                  </a:txBody>
+                  <a:tcPr/>
+                </a:tc>
+                <a:tc>
+                  <a:txBody>
+                    <a:bodyPr/>
+                    <a:lstStyle/>
+                    <a:p>
+                      <a:pPr>
+                        <a:defRPr sz="1000" b="0">
+                          <a:solidFill>
+                            <a:srgbClr val="1E293B"/>
+                          </a:solidFill>
+                          <a:latin typeface="Arial"/>
+                        </a:defRPr>
+                      </a:pPr>
+                      <a:r>
                         <a:t>3</a:t>
                       </a:r>
                     </a:p>
@@ -3869,7 +4014,7 @@
                   <a:tcPr/>
                 </a:tc>
               </a:tr>
-              <a:tr h="548640">
+              <a:tr h="525780">
                 <a:tc>
                   <a:txBody>
                     <a:bodyPr/>
@@ -3944,6 +4089,26 @@
                         </a:defRPr>
                       </a:pPr>
                       <a:r>
+                        <a:t>GA (all)</a:t>
+                      </a:r>
+                    </a:p>
+                  </a:txBody>
+                  <a:tcPr/>
+                </a:tc>
+                <a:tc>
+                  <a:txBody>
+                    <a:bodyPr/>
+                    <a:lstStyle/>
+                    <a:p>
+                      <a:pPr>
+                        <a:defRPr sz="1000" b="0">
+                          <a:solidFill>
+                            <a:srgbClr val="1E293B"/>
+                          </a:solidFill>
+                          <a:latin typeface="Arial"/>
+                        </a:defRPr>
+                      </a:pPr>
+                      <a:r>
                         <a:t>15</a:t>
                       </a:r>
                     </a:p>
@@ -3963,8 +4128,8 @@
         </p:nvSpPr>
         <p:spPr>
           <a:xfrm>
-            <a:off x="1097280" y="5989320"/>
-            <a:ext cx="4572000" cy="274320"/>
+            <a:off x="640080" y="5806440"/>
+            <a:ext cx="10972800" cy="411480"/>
           </a:xfrm>
           <a:prstGeom prst="rect">
             <a:avLst/>
@@ -3986,7 +4151,7 @@
               </a:defRPr>
             </a:pPr>
             <a:r>
-              <a:t>■ May Batch Count (dark green)    ■ June Batch Count (light blue)</a:t>
+              <a:t>■ May Batch Count (dark green)    ■ June Batch Count (light blue)    ■ July — GA for all accounts (amber; no per-domain count)</a:t>
             </a:r>
           </a:p>
         </p:txBody>

</xml_diff>